<commit_message>
chore: Update CopilotSDKBackstageDemo presentation file
</commit_message>
<xml_diff>
--- a/presentations/CopilotSDKBackstageDemo.pptx
+++ b/presentations/CopilotSDKBackstageDemo.pptx
@@ -4,13 +4,13 @@
   <p:sldMasterIdLst>
     <p:sldMasterId id="2147483648" r:id="rId1"/>
   </p:sldMasterIdLst>
+  <p:notesMasterIdLst>
+    <p:notesMasterId r:id="rId4"/>
+  </p:notesMasterIdLst>
   <p:sldIdLst>
     <p:sldId id="256" r:id="rId2"/>
     <p:sldId id="257" r:id="rId3"/>
   </p:sldIdLst>
-  <p:notesMasterIdLst>
-    <p:notesMasterId r:id="rId4"/>
-  </p:notesMasterIdLst>
   <p:sldSz cx="12192000" cy="6858000"/>
   <p:notesSz cx="6858000" cy="12192000"/>
   <p:defaultTextStyle>
@@ -105,6 +105,11 @@
       </a:defRPr>
     </a:lvl9pPr>
   </p:defaultTextStyle>
+  <p:extLst>
+    <p:ext uri="{EFAFB233-063F-42B5-8137-9DF3F51BA10A}">
+      <p15:sldGuideLst xmlns:p15="http://schemas.microsoft.com/office/powerpoint/2012/main"/>
+    </p:ext>
+  </p:extLst>
 </p:presentation>
 </file>
 
@@ -130,234 +135,10 @@
           <a:chExt cx="0" cy="0"/>
         </a:xfrm>
       </p:grpSpPr>
-      <p:sp>
-        <p:nvSpPr>
-          <p:cNvPr id="2" name="Header Placeholder 1"/>
-          <p:cNvSpPr>
-            <a:spLocks noGrp="1"/>
-          </p:cNvSpPr>
-          <p:nvPr>
-            <p:ph type="hdr" sz="quarter"/>
-          </p:nvPr>
-        </p:nvSpPr>
-        <p:spPr>
-          <a:xfrm>
-            <a:off x="0" y="0"/>
-            <a:ext cx="2971800" cy="458788"/>
-          </a:xfrm>
-          <a:prstGeom prst="rect">
-            <a:avLst/>
-          </a:prstGeom>
-        </p:spPr>
-        <p:txBody>
-          <a:bodyPr vert="horz" lIns="91440" tIns="45720" rIns="91440" bIns="45720" rtlCol="0"/>
-          <a:lstStyle>
-            <a:lvl1pPr algn="l">
-              <a:defRPr sz="1200"/>
-            </a:lvl1pPr>
-          </a:lstStyle>
-          <a:p>
-            <a:endParaRPr lang="en-US"/>
-          </a:p>
-        </p:txBody>
-      </p:sp>
-      <p:sp>
-        <p:nvSpPr>
-          <p:cNvPr id="3" name="Date Placeholder 2"/>
-          <p:cNvSpPr>
-            <a:spLocks noGrp="1"/>
-          </p:cNvSpPr>
-          <p:nvPr>
-            <p:ph type="dt" idx="1"/>
-          </p:nvPr>
-        </p:nvSpPr>
-        <p:spPr>
-          <a:xfrm>
-            <a:off x="3884613" y="0"/>
-            <a:ext cx="2971800" cy="458788"/>
-          </a:xfrm>
-          <a:prstGeom prst="rect">
-            <a:avLst/>
-          </a:prstGeom>
-        </p:spPr>
-        <p:txBody>
-          <a:bodyPr vert="horz" lIns="91440" tIns="45720" rIns="91440" bIns="45720" rtlCol="0"/>
-          <a:lstStyle>
-            <a:lvl1pPr algn="r">
-              <a:defRPr sz="1200"/>
-            </a:lvl1pPr>
-          </a:lstStyle>
-          <a:p>
-            <a:fld id="{5282F153-3F37-0F45-9E97-73ACFA13230C}" type="datetimeFigureOut">
-              <a:rPr lang="en-US"/>
-              <a:t>7/23/19</a:t>
-            </a:fld>
-            <a:endParaRPr lang="en-US"/>
-          </a:p>
-        </p:txBody>
-      </p:sp>
-      <p:sp>
-        <p:nvSpPr>
-          <p:cNvPr id="4" name="Slide Image Placeholder 3"/>
-          <p:cNvSpPr>
-            <a:spLocks noGrp="1" noRot="1" noChangeAspect="1"/>
-          </p:cNvSpPr>
-          <p:nvPr>
-            <p:ph type="sldImg" idx="2"/>
-          </p:nvPr>
-        </p:nvSpPr>
-        <p:spPr>
-          <a:xfrm>
-            <a:off x="685800" y="1143000"/>
-            <a:ext cx="5486400" cy="3086100"/>
-          </a:xfrm>
-          <a:prstGeom prst="rect">
-            <a:avLst/>
-          </a:prstGeom>
-          <a:noFill/>
-          <a:ln w="12700">
-            <a:solidFill>
-              <a:prstClr val="black"/>
-            </a:solidFill>
-          </a:ln>
-        </p:spPr>
-        <p:txBody>
-          <a:bodyPr vert="horz" lIns="91440" tIns="45720" rIns="91440" bIns="45720" rtlCol="0" anchor="ctr"/>
-          <a:lstStyle/>
-          <a:p>
-            <a:endParaRPr lang="en-US"/>
-          </a:p>
-        </p:txBody>
-      </p:sp>
-      <p:sp>
-        <p:nvSpPr>
-          <p:cNvPr id="5" name="Notes Placeholder 4"/>
-          <p:cNvSpPr>
-            <a:spLocks noGrp="1"/>
-          </p:cNvSpPr>
-          <p:nvPr>
-            <p:ph type="body" sz="quarter" idx="3"/>
-          </p:nvPr>
-        </p:nvSpPr>
-        <p:spPr>
-          <a:xfrm>
-            <a:off x="685800" y="4400550"/>
-            <a:ext cx="5486400" cy="3600450"/>
-          </a:xfrm>
-          <a:prstGeom prst="rect">
-            <a:avLst/>
-          </a:prstGeom>
-        </p:spPr>
-        <p:txBody>
-          <a:bodyPr vert="horz" lIns="91440" tIns="45720" rIns="91440" bIns="45720" rtlCol="0"/>
-          <a:lstStyle/>
-          <a:p>
-            <a:pPr lvl="0"/>
-            <a:r>
-              <a:rPr lang="en-US"/>
-              <a:t>Click to edit Master text styles</a:t>
-            </a:r>
-          </a:p>
-          <a:p>
-            <a:pPr lvl="1"/>
-            <a:r>
-              <a:rPr lang="en-US"/>
-              <a:t>Second level</a:t>
-            </a:r>
-          </a:p>
-          <a:p>
-            <a:pPr lvl="2"/>
-            <a:r>
-              <a:rPr lang="en-US"/>
-              <a:t>Third level</a:t>
-            </a:r>
-          </a:p>
-          <a:p>
-            <a:pPr lvl="3"/>
-            <a:r>
-              <a:rPr lang="en-US"/>
-              <a:t>Fourth level</a:t>
-            </a:r>
-          </a:p>
-          <a:p>
-            <a:pPr lvl="4"/>
-            <a:r>
-              <a:rPr lang="en-US"/>
-              <a:t>Fifth level</a:t>
-            </a:r>
-          </a:p>
-        </p:txBody>
-      </p:sp>
-      <p:sp>
-        <p:nvSpPr>
-          <p:cNvPr id="6" name="Footer Placeholder 5"/>
-          <p:cNvSpPr>
-            <a:spLocks noGrp="1"/>
-          </p:cNvSpPr>
-          <p:nvPr>
-            <p:ph type="ftr" sz="quarter" idx="4"/>
-          </p:nvPr>
-        </p:nvSpPr>
-        <p:spPr>
-          <a:xfrm>
-            <a:off x="0" y="8685213"/>
-            <a:ext cx="2971800" cy="458787"/>
-          </a:xfrm>
-          <a:prstGeom prst="rect">
-            <a:avLst/>
-          </a:prstGeom>
-        </p:spPr>
-        <p:txBody>
-          <a:bodyPr vert="horz" lIns="91440" tIns="45720" rIns="91440" bIns="45720" rtlCol="0" anchor="b"/>
-          <a:lstStyle>
-            <a:lvl1pPr algn="l">
-              <a:defRPr sz="1200"/>
-            </a:lvl1pPr>
-          </a:lstStyle>
-          <a:p>
-            <a:endParaRPr lang="en-US"/>
-          </a:p>
-        </p:txBody>
-      </p:sp>
-      <p:sp>
-        <p:nvSpPr>
-          <p:cNvPr id="7" name="Slide Number Placeholder 6"/>
-          <p:cNvSpPr>
-            <a:spLocks noGrp="1"/>
-          </p:cNvSpPr>
-          <p:nvPr>
-            <p:ph type="sldNum" sz="quarter" idx="5"/>
-          </p:nvPr>
-        </p:nvSpPr>
-        <p:spPr>
-          <a:xfrm>
-            <a:off x="3884613" y="8685213"/>
-            <a:ext cx="2971800" cy="458787"/>
-          </a:xfrm>
-          <a:prstGeom prst="rect">
-            <a:avLst/>
-          </a:prstGeom>
-        </p:spPr>
-        <p:txBody>
-          <a:bodyPr vert="horz" lIns="91440" tIns="45720" rIns="91440" bIns="45720" rtlCol="0" anchor="b"/>
-          <a:lstStyle>
-            <a:lvl1pPr algn="r">
-              <a:defRPr sz="1200"/>
-            </a:lvl1pPr>
-          </a:lstStyle>
-          <a:p>
-            <a:fld id="{CE5E9CC1-C706-0F49-92D6-E571CC5EEA8F}" type="slidenum">
-              <a:rPr lang="en-US"/>
-              <a:t>‹#›</a:t>
-            </a:fld>
-            <a:endParaRPr lang="en-US"/>
-          </a:p>
-        </p:txBody>
-      </p:sp>
     </p:spTree>
     <p:extLst>
       <p:ext uri="{BB962C8B-B14F-4D97-AF65-F5344CB8AC3E}">
-        <p14:creationId xmlns:p14="http://schemas.microsoft.com/office/powerpoint/2010/main" val="1024086991"/>
+        <p14:creationId xmlns:p14="http://schemas.microsoft.com/office/powerpoint/2010/main" val="2339729572"/>
       </p:ext>
     </p:extLst>
   </p:cSld>
@@ -501,10 +282,6 @@
           <a:bodyPr/>
           <a:lstStyle/>
           <a:p>
-            <a:r>
-              <a:rPr lang="en-US" dirty="0"/>
-              <a:t/>
-            </a:r>
             <a:endParaRPr lang="en-US" dirty="0"/>
           </a:p>
         </p:txBody>
@@ -589,10 +366,6 @@
           <a:bodyPr/>
           <a:lstStyle/>
           <a:p>
-            <a:r>
-              <a:rPr lang="en-US" dirty="0"/>
-              <a:t/>
-            </a:r>
             <a:endParaRPr lang="en-US" dirty="0"/>
           </a:p>
         </p:txBody>
@@ -666,6 +439,11 @@
 <file path=ppt/slideMasters/slideMaster1.xml><?xml version="1.0" encoding="utf-8"?>
 <p:sldMaster xmlns:a="http://schemas.openxmlformats.org/drawingml/2006/main" xmlns:r="http://schemas.openxmlformats.org/officeDocument/2006/relationships" xmlns:p="http://schemas.openxmlformats.org/presentationml/2006/main">
   <p:cSld>
+    <p:bg>
+      <p:bgRef idx="1001">
+        <a:schemeClr val="bg1"/>
+      </p:bgRef>
+    </p:bg>
     <p:spTree>
       <p:nvGrpSpPr>
         <p:cNvPr id="1" name=""/>
@@ -948,6 +726,7 @@
         <a:solidFill>
           <a:srgbClr val="0F172A"/>
         </a:solidFill>
+        <a:effectLst/>
       </p:bgPr>
     </p:bg>
     <p:spTree>
@@ -988,6 +767,13 @@
             <a:prstDash val="solid"/>
           </a:ln>
         </p:spPr>
+        <p:txBody>
+          <a:bodyPr/>
+          <a:lstStyle/>
+          <a:p>
+            <a:endParaRPr lang="en-ES"/>
+          </a:p>
+        </p:txBody>
       </p:sp>
       <p:sp>
         <p:nvSpPr>
@@ -1017,6 +803,13 @@
             <a:prstDash val="solid"/>
           </a:ln>
         </p:spPr>
+        <p:txBody>
+          <a:bodyPr/>
+          <a:lstStyle/>
+          <a:p>
+            <a:endParaRPr lang="en-ES"/>
+          </a:p>
+        </p:txBody>
       </p:sp>
       <p:sp>
         <p:nvSpPr>
@@ -1046,6 +839,13 @@
             <a:prstDash val="solid"/>
           </a:ln>
         </p:spPr>
+        <p:txBody>
+          <a:bodyPr/>
+          <a:lstStyle/>
+          <a:p>
+            <a:endParaRPr lang="en-ES"/>
+          </a:p>
+        </p:txBody>
       </p:sp>
       <p:sp>
         <p:nvSpPr>
@@ -1071,6 +871,13 @@
             <a:prstDash val="solid"/>
           </a:ln>
         </p:spPr>
+        <p:txBody>
+          <a:bodyPr/>
+          <a:lstStyle/>
+          <a:p>
+            <a:endParaRPr lang="en-ES"/>
+          </a:p>
+        </p:txBody>
       </p:sp>
       <p:sp>
         <p:nvSpPr>
@@ -1093,7 +900,7 @@
           <a:bodyPr wrap="square" rtlCol="0" anchor="ctr"/>
           <a:lstStyle/>
           <a:p>
-            <a:pPr indent="0" marL="0">
+            <a:pPr marL="0" indent="0">
               <a:buNone/>
             </a:pPr>
             <a:r>
@@ -1132,7 +939,7 @@
           <a:bodyPr wrap="square" rtlCol="0" anchor="ctr"/>
           <a:lstStyle/>
           <a:p>
-            <a:pPr indent="0" marL="0">
+            <a:pPr marL="0" indent="0">
               <a:buNone/>
             </a:pPr>
             <a:r>
@@ -1144,7 +951,7 @@
                 <a:ea typeface="Arial" pitchFamily="34" charset="-122"/>
                 <a:cs typeface="Arial" pitchFamily="34" charset="-120"/>
               </a:rPr>
-              <a:t>Catalog-aware DevEx assistant for self-service engineering</a:t>
+              <a:t>A catalog-aware AI assistant for self-service engineering</a:t>
             </a:r>
             <a:endParaRPr lang="en-US" sz="1700" dirty="0"/>
           </a:p>
@@ -1171,7 +978,7 @@
           <a:bodyPr wrap="square" rtlCol="0" anchor="ctr"/>
           <a:lstStyle/>
           <a:p>
-            <a:pPr indent="0" marL="0">
+            <a:pPr marL="0" indent="0">
               <a:buNone/>
             </a:pPr>
             <a:r>
@@ -1183,7 +990,7 @@
                 <a:ea typeface="Arial" pitchFamily="34" charset="-122"/>
                 <a:cs typeface="Arial" pitchFamily="34" charset="-120"/>
               </a:rPr>
-              <a:t>Business value</a:t>
+              <a:t>Developer impact</a:t>
             </a:r>
             <a:endParaRPr lang="en-US" sz="1600" dirty="0"/>
           </a:p>
@@ -1213,13 +1020,20 @@
             <a:prstDash val="solid"/>
           </a:ln>
           <a:effectLst>
-            <a:outerShdw sx="100000" sy="100000" kx="0" ky="0" algn="bl" rotWithShape="0" blurRad="76200" dist="50800" dir="2700000">
+            <a:outerShdw blurRad="76200" dist="50800" dir="2700000" algn="bl" rotWithShape="0">
               <a:srgbClr val="000000">
                 <a:alpha val="18000"/>
               </a:srgbClr>
             </a:outerShdw>
           </a:effectLst>
         </p:spPr>
+        <p:txBody>
+          <a:bodyPr/>
+          <a:lstStyle/>
+          <a:p>
+            <a:endParaRPr lang="en-ES"/>
+          </a:p>
+        </p:txBody>
       </p:sp>
       <p:sp>
         <p:nvSpPr>
@@ -1245,6 +1059,13 @@
             <a:prstDash val="solid"/>
           </a:ln>
         </p:spPr>
+        <p:txBody>
+          <a:bodyPr/>
+          <a:lstStyle/>
+          <a:p>
+            <a:endParaRPr lang="en-ES"/>
+          </a:p>
+        </p:txBody>
       </p:sp>
       <p:sp>
         <p:nvSpPr>
@@ -1254,7 +1075,7 @@
         </p:nvSpPr>
         <p:spPr>
           <a:xfrm>
-            <a:off x="1051560" y="2560320"/>
+            <a:off x="1051560" y="2633472"/>
             <a:ext cx="530352" cy="530352"/>
           </a:xfrm>
           <a:prstGeom prst="rect">
@@ -1267,21 +1088,12 @@
           <a:bodyPr wrap="square" rtlCol="0" anchor="ctr"/>
           <a:lstStyle/>
           <a:p>
-            <a:pPr algn="ctr" indent="0" marL="0">
-              <a:buNone/>
-            </a:pPr>
-            <a:r>
-              <a:rPr lang="en-US" sz="1800" b="1" dirty="0">
-                <a:solidFill>
-                  <a:srgbClr val="FFFFFF"/>
-                </a:solidFill>
-                <a:latin typeface="Arial" pitchFamily="34" charset="0"/>
-                <a:ea typeface="Arial" pitchFamily="34" charset="-122"/>
-                <a:cs typeface="Arial" pitchFamily="34" charset="-120"/>
-              </a:rPr>
-              <a:t>1</a:t>
-            </a:r>
-            <a:endParaRPr lang="en-US" sz="1800" dirty="0"/>
+            <a:pPr algn="ctr"/>
+            <a:r>
+              <a:rPr lang="en-ES" sz="2400" dirty="0"/>
+              <a:t>🚀</a:t>
+            </a:r>
+            <a:endParaRPr lang="en-US" sz="2400" dirty="0"/>
           </a:p>
         </p:txBody>
       </p:sp>
@@ -1306,7 +1118,7 @@
           <a:bodyPr wrap="square" rtlCol="0" anchor="ctr"/>
           <a:lstStyle/>
           <a:p>
-            <a:pPr indent="0" marL="0">
+            <a:pPr marL="0" indent="0">
               <a:buNone/>
             </a:pPr>
             <a:r>
@@ -1318,7 +1130,7 @@
                 <a:ea typeface="Arial" pitchFamily="34" charset="-122"/>
                 <a:cs typeface="Arial" pitchFamily="34" charset="-120"/>
               </a:rPr>
-              <a:t>Faster onboarding</a:t>
+              <a:t>Instant developer onboarding</a:t>
             </a:r>
             <a:endParaRPr lang="en-US" sz="1600" dirty="0"/>
           </a:p>
@@ -1345,19 +1157,20 @@
           <a:bodyPr wrap="square" rtlCol="0" anchor="t"/>
           <a:lstStyle/>
           <a:p>
-            <a:pPr indent="0" marL="0">
-              <a:buNone/>
-            </a:pPr>
-            <a:r>
-              <a:rPr lang="en-US" sz="1200" dirty="0">
-                <a:solidFill>
-                  <a:srgbClr val="475569"/>
-                </a:solidFill>
-                <a:latin typeface="Arial" pitchFamily="34" charset="0"/>
-                <a:ea typeface="Arial" pitchFamily="34" charset="-122"/>
-                <a:cs typeface="Arial" pitchFamily="34" charset="-120"/>
-              </a:rPr>
-              <a:t>Answers grounded in Backstage Catalog context (ownership, service metadata, docs).</a:t>
+            <a:r>
+              <a:rPr lang="en-GB" sz="1200" b="1" dirty="0"/>
+              <a:t>Answers grounded in your Backstage </a:t>
+            </a:r>
+            <a:r>
+              <a:rPr lang="en-GB" sz="1200" b="1" dirty="0" err="1"/>
+              <a:t>catalog</a:t>
+            </a:r>
+            <a:br>
+              <a:rPr lang="en-GB" sz="1200" dirty="0"/>
+            </a:br>
+            <a:r>
+              <a:rPr lang="en-GB" sz="1200" dirty="0"/>
+              <a:t>Ownership • Service metadata • Docs</a:t>
             </a:r>
             <a:endParaRPr lang="en-US" sz="1200" dirty="0"/>
           </a:p>
@@ -1387,13 +1200,20 @@
             <a:prstDash val="solid"/>
           </a:ln>
           <a:effectLst>
-            <a:outerShdw sx="100000" sy="100000" kx="0" ky="0" algn="bl" rotWithShape="0" blurRad="76200" dist="50800" dir="2700000">
+            <a:outerShdw blurRad="76200" dist="50800" dir="2700000" algn="bl" rotWithShape="0">
               <a:srgbClr val="000000">
                 <a:alpha val="18000"/>
               </a:srgbClr>
             </a:outerShdw>
           </a:effectLst>
         </p:spPr>
+        <p:txBody>
+          <a:bodyPr/>
+          <a:lstStyle/>
+          <a:p>
+            <a:endParaRPr lang="en-ES"/>
+          </a:p>
+        </p:txBody>
       </p:sp>
       <p:sp>
         <p:nvSpPr>
@@ -1419,6 +1239,13 @@
             <a:prstDash val="solid"/>
           </a:ln>
         </p:spPr>
+        <p:txBody>
+          <a:bodyPr/>
+          <a:lstStyle/>
+          <a:p>
+            <a:endParaRPr lang="en-ES"/>
+          </a:p>
+        </p:txBody>
       </p:sp>
       <p:sp>
         <p:nvSpPr>
@@ -1428,7 +1255,7 @@
         </p:nvSpPr>
         <p:spPr>
           <a:xfrm>
-            <a:off x="1051560" y="3794760"/>
+            <a:off x="1051560" y="3867912"/>
             <a:ext cx="530352" cy="530352"/>
           </a:xfrm>
           <a:prstGeom prst="rect">
@@ -1441,21 +1268,12 @@
           <a:bodyPr wrap="square" rtlCol="0" anchor="ctr"/>
           <a:lstStyle/>
           <a:p>
-            <a:pPr algn="ctr" indent="0" marL="0">
-              <a:buNone/>
-            </a:pPr>
-            <a:r>
-              <a:rPr lang="en-US" sz="1800" b="1" dirty="0">
-                <a:solidFill>
-                  <a:srgbClr val="FFFFFF"/>
-                </a:solidFill>
-                <a:latin typeface="Arial" pitchFamily="34" charset="0"/>
-                <a:ea typeface="Arial" pitchFamily="34" charset="-122"/>
-                <a:cs typeface="Arial" pitchFamily="34" charset="-120"/>
-              </a:rPr>
-              <a:t>2</a:t>
-            </a:r>
-            <a:endParaRPr lang="en-US" sz="1800" dirty="0"/>
+            <a:pPr algn="ctr"/>
+            <a:r>
+              <a:rPr lang="en-ES" sz="2400" dirty="0"/>
+              <a:t>💬</a:t>
+            </a:r>
+            <a:endParaRPr lang="en-US" sz="2400" dirty="0"/>
           </a:p>
         </p:txBody>
       </p:sp>
@@ -1480,7 +1298,7 @@
           <a:bodyPr wrap="square" rtlCol="0" anchor="ctr"/>
           <a:lstStyle/>
           <a:p>
-            <a:pPr indent="0" marL="0">
+            <a:pPr marL="0" indent="0">
               <a:buNone/>
             </a:pPr>
             <a:r>
@@ -1519,7 +1337,7 @@
           <a:bodyPr wrap="square" rtlCol="0" anchor="t"/>
           <a:lstStyle/>
           <a:p>
-            <a:pPr indent="0" marL="0">
+            <a:pPr marL="0" indent="0">
               <a:buNone/>
             </a:pPr>
             <a:r>
@@ -1531,7 +1349,7 @@
                 <a:ea typeface="Arial" pitchFamily="34" charset="-122"/>
                 <a:cs typeface="Arial" pitchFamily="34" charset="-120"/>
               </a:rPr>
-              <a:t>Chat in Backstage and trigger actions via GitHub MCP tools — without leaving the portal.</a:t>
+              <a:t>Chat in Backstage and trigger actions via MCP tools — without leaving the portal.</a:t>
             </a:r>
             <a:endParaRPr lang="en-US" sz="1200" dirty="0"/>
           </a:p>
@@ -1561,13 +1379,20 @@
             <a:prstDash val="solid"/>
           </a:ln>
           <a:effectLst>
-            <a:outerShdw sx="100000" sy="100000" kx="0" ky="0" algn="bl" rotWithShape="0" blurRad="76200" dist="50800" dir="2700000">
+            <a:outerShdw blurRad="76200" dist="50800" dir="2700000" algn="bl" rotWithShape="0">
               <a:srgbClr val="000000">
                 <a:alpha val="18000"/>
               </a:srgbClr>
             </a:outerShdw>
           </a:effectLst>
         </p:spPr>
+        <p:txBody>
+          <a:bodyPr/>
+          <a:lstStyle/>
+          <a:p>
+            <a:endParaRPr lang="en-ES"/>
+          </a:p>
+        </p:txBody>
       </p:sp>
       <p:sp>
         <p:nvSpPr>
@@ -1593,6 +1418,13 @@
             <a:prstDash val="solid"/>
           </a:ln>
         </p:spPr>
+        <p:txBody>
+          <a:bodyPr/>
+          <a:lstStyle/>
+          <a:p>
+            <a:endParaRPr lang="en-ES"/>
+          </a:p>
+        </p:txBody>
       </p:sp>
       <p:sp>
         <p:nvSpPr>
@@ -1602,7 +1434,7 @@
         </p:nvSpPr>
         <p:spPr>
           <a:xfrm>
-            <a:off x="1051560" y="5029200"/>
+            <a:off x="1051560" y="5093208"/>
             <a:ext cx="530352" cy="530352"/>
           </a:xfrm>
           <a:prstGeom prst="rect">
@@ -1615,21 +1447,12 @@
           <a:bodyPr wrap="square" rtlCol="0" anchor="ctr"/>
           <a:lstStyle/>
           <a:p>
-            <a:pPr algn="ctr" indent="0" marL="0">
-              <a:buNone/>
-            </a:pPr>
-            <a:r>
-              <a:rPr lang="en-US" sz="1800" b="1" dirty="0">
-                <a:solidFill>
-                  <a:srgbClr val="FFFFFF"/>
-                </a:solidFill>
-                <a:latin typeface="Arial" pitchFamily="34" charset="0"/>
-                <a:ea typeface="Arial" pitchFamily="34" charset="-122"/>
-                <a:cs typeface="Arial" pitchFamily="34" charset="-120"/>
-              </a:rPr>
-              <a:t>3</a:t>
-            </a:r>
-            <a:endParaRPr lang="en-US" sz="1800" dirty="0"/>
+            <a:pPr algn="ctr"/>
+            <a:r>
+              <a:rPr lang="en-ES" sz="2400" dirty="0"/>
+              <a:t>🛡</a:t>
+            </a:r>
+            <a:endParaRPr lang="en-US" sz="2400" dirty="0"/>
           </a:p>
         </p:txBody>
       </p:sp>
@@ -1654,7 +1477,7 @@
           <a:bodyPr wrap="square" rtlCol="0" anchor="ctr"/>
           <a:lstStyle/>
           <a:p>
-            <a:pPr indent="0" marL="0">
+            <a:pPr marL="0" indent="0">
               <a:buNone/>
             </a:pPr>
             <a:r>
@@ -1666,7 +1489,7 @@
                 <a:ea typeface="Arial" pitchFamily="34" charset="-122"/>
                 <a:cs typeface="Arial" pitchFamily="34" charset="-120"/>
               </a:rPr>
-              <a:t>Safer delivery</a:t>
+              <a:t>Enterprise-ready AI</a:t>
             </a:r>
             <a:endParaRPr lang="en-US" sz="1600" dirty="0"/>
           </a:p>
@@ -1693,7 +1516,7 @@
           <a:bodyPr wrap="square" rtlCol="0" anchor="t"/>
           <a:lstStyle/>
           <a:p>
-            <a:pPr indent="0" marL="0">
+            <a:pPr marL="0" indent="0">
               <a:buNone/>
             </a:pPr>
             <a:r>
@@ -1735,6 +1558,13 @@
             <a:prstDash val="solid"/>
           </a:ln>
         </p:spPr>
+        <p:txBody>
+          <a:bodyPr/>
+          <a:lstStyle/>
+          <a:p>
+            <a:endParaRPr lang="en-ES"/>
+          </a:p>
+        </p:txBody>
       </p:sp>
       <p:sp>
         <p:nvSpPr>
@@ -1757,7 +1587,7 @@
           <a:bodyPr wrap="square" rtlCol="0" anchor="ctr"/>
           <a:lstStyle/>
           <a:p>
-            <a:pPr indent="0" marL="0">
+            <a:pPr marL="0" indent="0">
               <a:buNone/>
             </a:pPr>
             <a:r>
@@ -1769,48 +1599,32 @@
                 <a:ea typeface="Arial" pitchFamily="34" charset="-122"/>
                 <a:cs typeface="Arial" pitchFamily="34" charset="-120"/>
               </a:rPr>
-              <a:t>Repo: https://github.com/0GiS0/backstage-github-copilot-sdk-demo</a:t>
-            </a:r>
-            <a:endParaRPr lang="en-US" sz="1300" dirty="0"/>
-          </a:p>
-        </p:txBody>
-      </p:sp>
-      <p:sp>
-        <p:nvSpPr>
-          <p:cNvPr id="26" name="Text 24"/>
-          <p:cNvSpPr/>
-          <p:nvPr/>
-        </p:nvSpPr>
-        <p:spPr>
-          <a:xfrm>
-            <a:off x="822960" y="6629400"/>
-            <a:ext cx="10789920" cy="201168"/>
-          </a:xfrm>
-          <a:prstGeom prst="rect">
-            <a:avLst/>
-          </a:prstGeom>
-          <a:noFill/>
-          <a:ln/>
-        </p:spPr>
-        <p:txBody>
-          <a:bodyPr wrap="square" rtlCol="0" anchor="ctr"/>
-          <a:lstStyle/>
-          <a:p>
-            <a:pPr indent="0" marL="0">
-              <a:buNone/>
-            </a:pPr>
-            <a:r>
-              <a:rPr lang="en-US" sz="900" dirty="0">
+              <a:t>Demo repo: </a:t>
+            </a:r>
+            <a:r>
+              <a:rPr lang="en-US" sz="1300" dirty="0">
                 <a:solidFill>
-                  <a:srgbClr val="D1D5DB"/>
+                  <a:srgbClr val="2DA44E"/>
+                </a:solidFill>
+                <a:latin typeface="Arial" pitchFamily="34" charset="0"/>
+                <a:ea typeface="Arial" pitchFamily="34" charset="-122"/>
+                <a:cs typeface="Arial" pitchFamily="34" charset="-120"/>
+                <a:hlinkClick r:id="rId3"/>
+              </a:rPr>
+              <a:t>https://github.com/0GiS0/backstage-github-copilot-sdk-demo</a:t>
+            </a:r>
+            <a:r>
+              <a:rPr lang="en-US" sz="1300" dirty="0">
+                <a:solidFill>
+                  <a:srgbClr val="2DA44E"/>
                 </a:solidFill>
                 <a:latin typeface="Arial" pitchFamily="34" charset="0"/>
                 <a:ea typeface="Arial" pitchFamily="34" charset="-122"/>
                 <a:cs typeface="Arial" pitchFamily="34" charset="-120"/>
               </a:rPr>
-              <a:t>GitHub Copilot SDK Enterprise Challenge • 1–2 slides</a:t>
-            </a:r>
-            <a:endParaRPr lang="en-US" sz="900" dirty="0"/>
+              <a:t> </a:t>
+            </a:r>
+            <a:endParaRPr lang="en-US" sz="1300" dirty="0"/>
           </a:p>
         </p:txBody>
       </p:sp>
@@ -1830,6 +1644,7 @@
         <a:solidFill>
           <a:srgbClr val="FFFFFF"/>
         </a:solidFill>
+        <a:effectLst/>
       </p:bgPr>
     </p:bg>
     <p:spTree>
@@ -1854,7 +1669,7 @@
         </p:nvSpPr>
         <p:spPr>
           <a:xfrm>
-            <a:off x="731520" y="365760"/>
+            <a:off x="498318" y="251460"/>
             <a:ext cx="10789920" cy="731520"/>
           </a:xfrm>
           <a:prstGeom prst="rect">
@@ -1867,7 +1682,7 @@
           <a:bodyPr wrap="square" rtlCol="0" anchor="ctr"/>
           <a:lstStyle/>
           <a:p>
-            <a:pPr indent="0" marL="0">
+            <a:pPr marL="0" indent="0">
               <a:buNone/>
             </a:pPr>
             <a:r>
@@ -1879,7 +1694,7 @@
                 <a:ea typeface="Arial" pitchFamily="34" charset="-122"/>
                 <a:cs typeface="Arial" pitchFamily="34" charset="-120"/>
               </a:rPr>
-              <a:t>Architecture</a:t>
+              <a:t>Backstage + Copilot SDK architecture</a:t>
             </a:r>
             <a:endParaRPr lang="en-US" sz="3200" dirty="0"/>
           </a:p>
@@ -1887,52 +1702,13 @@
       </p:sp>
       <p:sp>
         <p:nvSpPr>
-          <p:cNvPr id="3" name="Text 1"/>
-          <p:cNvSpPr/>
-          <p:nvPr/>
-        </p:nvSpPr>
-        <p:spPr>
-          <a:xfrm>
-            <a:off x="731520" y="1051560"/>
-            <a:ext cx="11155680" cy="274320"/>
-          </a:xfrm>
-          <a:prstGeom prst="rect">
-            <a:avLst/>
-          </a:prstGeom>
-          <a:noFill/>
-          <a:ln/>
-        </p:spPr>
-        <p:txBody>
-          <a:bodyPr wrap="square" rtlCol="0" anchor="ctr"/>
-          <a:lstStyle/>
-          <a:p>
-            <a:pPr indent="0" marL="0">
-              <a:buNone/>
-            </a:pPr>
-            <a:r>
-              <a:rPr lang="en-US" sz="1000" dirty="0">
-                <a:solidFill>
-                  <a:srgbClr val="475569"/>
-                </a:solidFill>
-                <a:latin typeface="Arial" pitchFamily="34" charset="0"/>
-                <a:ea typeface="Arial" pitchFamily="34" charset="-122"/>
-                <a:cs typeface="Arial" pitchFamily="34" charset="-120"/>
-              </a:rPr>
-              <a:t>High-level flow (left → right): User → Backstage Portal (Chat) → Copilot SDK implementation → GitHub Copilot   •   Repo: https://github.com/0GiS0/backstage-github-copilot-sdk-demo</a:t>
-            </a:r>
-            <a:endParaRPr lang="en-US" sz="1000" dirty="0"/>
-          </a:p>
-        </p:txBody>
-      </p:sp>
-      <p:sp>
-        <p:nvSpPr>
           <p:cNvPr id="4" name="Shape 2"/>
           <p:cNvSpPr/>
           <p:nvPr/>
         </p:nvSpPr>
         <p:spPr>
           <a:xfrm>
-            <a:off x="548640" y="2377440"/>
+            <a:off x="498318" y="2708833"/>
             <a:ext cx="1920240" cy="1097280"/>
           </a:xfrm>
           <a:prstGeom prst="roundRect">
@@ -1948,6 +1724,13 @@
             <a:prstDash val="solid"/>
           </a:ln>
         </p:spPr>
+        <p:txBody>
+          <a:bodyPr/>
+          <a:lstStyle/>
+          <a:p>
+            <a:endParaRPr lang="en-ES"/>
+          </a:p>
+        </p:txBody>
       </p:sp>
       <p:sp>
         <p:nvSpPr>
@@ -1957,7 +1740,7 @@
         </p:nvSpPr>
         <p:spPr>
           <a:xfrm>
-            <a:off x="731520" y="2514600"/>
+            <a:off x="681198" y="2845993"/>
             <a:ext cx="1554480" cy="320040"/>
           </a:xfrm>
           <a:prstGeom prst="rect">
@@ -1970,9 +1753,10 @@
           <a:bodyPr wrap="square" rtlCol="0" anchor="ctr"/>
           <a:lstStyle/>
           <a:p>
-            <a:pPr indent="0" marL="0">
-              <a:buNone/>
-            </a:pPr>
+            <a:r>
+              <a:rPr lang="en-ES" sz="1400" dirty="0"/>
+              <a:t>👤 </a:t>
+            </a:r>
             <a:r>
               <a:rPr lang="en-US" sz="1400" b="1" dirty="0">
                 <a:solidFill>
@@ -1996,7 +1780,7 @@
         </p:nvSpPr>
         <p:spPr>
           <a:xfrm>
-            <a:off x="731520" y="2880360"/>
+            <a:off x="681198" y="3211753"/>
             <a:ext cx="1554480" cy="457200"/>
           </a:xfrm>
           <a:prstGeom prst="rect">
@@ -2009,7 +1793,7 @@
           <a:bodyPr wrap="square" rtlCol="0" anchor="t"/>
           <a:lstStyle/>
           <a:p>
-            <a:pPr indent="0" marL="0">
+            <a:pPr marL="0" indent="0">
               <a:buNone/>
             </a:pPr>
             <a:r>
@@ -2026,7 +1810,7 @@
             <a:endParaRPr lang="en-US" sz="1100" dirty="0"/>
           </a:p>
           <a:p>
-            <a:pPr indent="0" marL="0">
+            <a:pPr marL="0" indent="0">
               <a:buNone/>
             </a:pPr>
             <a:r>
@@ -2052,7 +1836,7 @@
         </p:nvSpPr>
         <p:spPr>
           <a:xfrm>
-            <a:off x="2651760" y="2148840"/>
+            <a:off x="2601438" y="2480233"/>
             <a:ext cx="2834640" cy="1554480"/>
           </a:xfrm>
           <a:prstGeom prst="roundRect">
@@ -2068,6 +1852,13 @@
             <a:prstDash val="solid"/>
           </a:ln>
         </p:spPr>
+        <p:txBody>
+          <a:bodyPr/>
+          <a:lstStyle/>
+          <a:p>
+            <a:endParaRPr lang="en-ES"/>
+          </a:p>
+        </p:txBody>
       </p:sp>
       <p:sp>
         <p:nvSpPr>
@@ -2077,7 +1868,7 @@
         </p:nvSpPr>
         <p:spPr>
           <a:xfrm>
-            <a:off x="2834640" y="2286000"/>
+            <a:off x="2784318" y="2617393"/>
             <a:ext cx="2468880" cy="320040"/>
           </a:xfrm>
           <a:prstGeom prst="rect">
@@ -2090,9 +1881,6 @@
           <a:bodyPr wrap="square" rtlCol="0" anchor="ctr"/>
           <a:lstStyle/>
           <a:p>
-            <a:pPr indent="0" marL="0">
-              <a:buNone/>
-            </a:pPr>
             <a:r>
               <a:rPr lang="en-US" sz="1400" b="1" dirty="0">
                 <a:solidFill>
@@ -2102,7 +1890,7 @@
                 <a:ea typeface="Arial" pitchFamily="34" charset="-122"/>
                 <a:cs typeface="Arial" pitchFamily="34" charset="-120"/>
               </a:rPr>
-              <a:t>Backstage Portal</a:t>
+              <a:t>🎙️ Backstage Portal</a:t>
             </a:r>
             <a:endParaRPr lang="en-US" sz="1400" dirty="0"/>
           </a:p>
@@ -2116,7 +1904,7 @@
         </p:nvSpPr>
         <p:spPr>
           <a:xfrm>
-            <a:off x="2834640" y="2651760"/>
+            <a:off x="2784318" y="2983153"/>
             <a:ext cx="2468880" cy="914400"/>
           </a:xfrm>
           <a:prstGeom prst="rect">
@@ -2129,7 +1917,7 @@
           <a:bodyPr wrap="square" rtlCol="0" anchor="t"/>
           <a:lstStyle/>
           <a:p>
-            <a:pPr indent="0" marL="0">
+            <a:pPr marL="0" indent="0">
               <a:buNone/>
             </a:pPr>
             <a:r>
@@ -2146,7 +1934,7 @@
             <a:endParaRPr lang="en-US" sz="1100" dirty="0"/>
           </a:p>
           <a:p>
-            <a:pPr indent="0" marL="0">
+            <a:pPr marL="0" indent="0">
               <a:buNone/>
             </a:pPr>
             <a:r>
@@ -2172,7 +1960,7 @@
         </p:nvSpPr>
         <p:spPr>
           <a:xfrm>
-            <a:off x="5760720" y="1737360"/>
+            <a:off x="5710398" y="2068753"/>
             <a:ext cx="3566160" cy="2377440"/>
           </a:xfrm>
           <a:prstGeom prst="roundRect">
@@ -2188,6 +1976,13 @@
             <a:prstDash val="solid"/>
           </a:ln>
         </p:spPr>
+        <p:txBody>
+          <a:bodyPr/>
+          <a:lstStyle/>
+          <a:p>
+            <a:endParaRPr lang="en-ES"/>
+          </a:p>
+        </p:txBody>
       </p:sp>
       <p:sp>
         <p:nvSpPr>
@@ -2197,7 +1992,7 @@
         </p:nvSpPr>
         <p:spPr>
           <a:xfrm>
-            <a:off x="5943600" y="1874520"/>
+            <a:off x="5893278" y="2205913"/>
             <a:ext cx="3200400" cy="320040"/>
           </a:xfrm>
           <a:prstGeom prst="rect">
@@ -2210,9 +2005,10 @@
           <a:bodyPr wrap="square" rtlCol="0" anchor="ctr"/>
           <a:lstStyle/>
           <a:p>
-            <a:pPr indent="0" marL="0">
-              <a:buNone/>
-            </a:pPr>
+            <a:r>
+              <a:rPr lang="en-ES" sz="1400" dirty="0"/>
+              <a:t>🤖 </a:t>
+            </a:r>
             <a:r>
               <a:rPr lang="en-US" sz="1400" b="1" dirty="0">
                 <a:solidFill>
@@ -2236,7 +2032,7 @@
         </p:nvSpPr>
         <p:spPr>
           <a:xfrm>
-            <a:off x="5943600" y="2240280"/>
+            <a:off x="5893278" y="2663113"/>
             <a:ext cx="3200400" cy="1737360"/>
           </a:xfrm>
           <a:prstGeom prst="rect">
@@ -2249,72 +2045,56 @@
           <a:bodyPr wrap="square" rtlCol="0" anchor="t"/>
           <a:lstStyle/>
           <a:p>
-            <a:pPr indent="0" marL="0">
-              <a:buNone/>
+            <a:pPr>
+              <a:lnSpc>
+                <a:spcPct val="150000"/>
+              </a:lnSpc>
             </a:pPr>
             <a:r>
-              <a:rPr lang="en-US" sz="1100" dirty="0">
-                <a:solidFill>
-                  <a:srgbClr val="475569"/>
-                </a:solidFill>
-                <a:latin typeface="Arial" pitchFamily="34" charset="0"/>
-                <a:ea typeface="Arial" pitchFamily="34" charset="-122"/>
-                <a:cs typeface="Arial" pitchFamily="34" charset="-120"/>
-              </a:rPr>
-              <a:t>• Custom agent: Backstage expert</a:t>
-            </a:r>
-            <a:endParaRPr lang="en-US" sz="1100" dirty="0"/>
-          </a:p>
-          <a:p>
-            <a:pPr indent="0" marL="0">
-              <a:buNone/>
+              <a:rPr lang="en-GB" sz="1100" dirty="0"/>
+              <a:t>Backstage expert agent</a:t>
+            </a:r>
+          </a:p>
+          <a:p>
+            <a:pPr>
+              <a:lnSpc>
+                <a:spcPct val="150000"/>
+              </a:lnSpc>
             </a:pPr>
             <a:r>
-              <a:rPr lang="en-US" sz="1100" dirty="0">
-                <a:solidFill>
-                  <a:srgbClr val="475569"/>
-                </a:solidFill>
-                <a:latin typeface="Arial" pitchFamily="34" charset="0"/>
-                <a:ea typeface="Arial" pitchFamily="34" charset="-122"/>
-                <a:cs typeface="Arial" pitchFamily="34" charset="-120"/>
-              </a:rPr>
-              <a:t>• MCP server: GitHub</a:t>
-            </a:r>
-            <a:endParaRPr lang="en-US" sz="1100" dirty="0"/>
-          </a:p>
-          <a:p>
-            <a:pPr indent="0" marL="0">
-              <a:buNone/>
+              <a:rPr lang="en-GB" sz="1100" dirty="0"/>
+              <a:t>GitHub MCP server</a:t>
+            </a:r>
+          </a:p>
+          <a:p>
+            <a:pPr>
+              <a:lnSpc>
+                <a:spcPct val="150000"/>
+              </a:lnSpc>
             </a:pPr>
             <a:r>
-              <a:rPr lang="en-US" sz="1100" dirty="0">
-                <a:solidFill>
-                  <a:srgbClr val="475569"/>
-                </a:solidFill>
-                <a:latin typeface="Arial" pitchFamily="34" charset="0"/>
-                <a:ea typeface="Arial" pitchFamily="34" charset="-122"/>
-                <a:cs typeface="Arial" pitchFamily="34" charset="-120"/>
-              </a:rPr>
-              <a:t>• MCP server: Backstage internal</a:t>
-            </a:r>
-            <a:endParaRPr lang="en-US" sz="1100" dirty="0"/>
-          </a:p>
-          <a:p>
-            <a:pPr indent="0" marL="0">
-              <a:buNone/>
+              <a:rPr lang="en-GB" sz="1100" dirty="0"/>
+              <a:t>Backstage MCP server</a:t>
+            </a:r>
+          </a:p>
+          <a:p>
+            <a:pPr>
+              <a:lnSpc>
+                <a:spcPct val="150000"/>
+              </a:lnSpc>
             </a:pPr>
             <a:r>
-              <a:rPr lang="en-US" sz="1100" dirty="0">
-                <a:solidFill>
-                  <a:srgbClr val="475569"/>
-                </a:solidFill>
-                <a:latin typeface="Arial" pitchFamily="34" charset="0"/>
-                <a:ea typeface="Arial" pitchFamily="34" charset="-122"/>
-                <a:cs typeface="Arial" pitchFamily="34" charset="-120"/>
-              </a:rPr>
-              <a:t>• Custom tools (catalog, templates, etc.)</a:t>
-            </a:r>
-            <a:endParaRPr lang="en-US" sz="1100" dirty="0"/>
+              <a:rPr lang="en-GB" sz="1100" dirty="0"/>
+              <a:t>Custom tools (</a:t>
+            </a:r>
+            <a:r>
+              <a:rPr lang="en-GB" sz="1100" dirty="0" err="1"/>
+              <a:t>catalog</a:t>
+            </a:r>
+            <a:r>
+              <a:rPr lang="en-GB" sz="1100" dirty="0"/>
+              <a:t>, templates)</a:t>
+            </a:r>
           </a:p>
         </p:txBody>
       </p:sp>
@@ -2326,7 +2106,7 @@
         </p:nvSpPr>
         <p:spPr>
           <a:xfrm>
-            <a:off x="9692640" y="2377440"/>
+            <a:off x="9642318" y="2708833"/>
             <a:ext cx="2011680" cy="1097280"/>
           </a:xfrm>
           <a:prstGeom prst="roundRect">
@@ -2342,6 +2122,13 @@
             <a:prstDash val="solid"/>
           </a:ln>
         </p:spPr>
+        <p:txBody>
+          <a:bodyPr/>
+          <a:lstStyle/>
+          <a:p>
+            <a:endParaRPr lang="en-ES"/>
+          </a:p>
+        </p:txBody>
       </p:sp>
       <p:sp>
         <p:nvSpPr>
@@ -2351,8 +2138,8 @@
         </p:nvSpPr>
         <p:spPr>
           <a:xfrm>
-            <a:off x="9875520" y="2514600"/>
-            <a:ext cx="1645920" cy="320040"/>
+            <a:off x="9825198" y="2845993"/>
+            <a:ext cx="1758532" cy="320040"/>
           </a:xfrm>
           <a:prstGeom prst="rect">
             <a:avLst/>
@@ -2364,9 +2151,10 @@
           <a:bodyPr wrap="square" rtlCol="0" anchor="ctr"/>
           <a:lstStyle/>
           <a:p>
-            <a:pPr indent="0" marL="0">
-              <a:buNone/>
-            </a:pPr>
+            <a:r>
+              <a:rPr lang="en-ES" sz="1400" dirty="0"/>
+              <a:t>✨ </a:t>
+            </a:r>
             <a:r>
               <a:rPr lang="en-US" sz="1400" b="1" dirty="0">
                 <a:solidFill>
@@ -2390,7 +2178,7 @@
         </p:nvSpPr>
         <p:spPr>
           <a:xfrm>
-            <a:off x="9875520" y="2880360"/>
+            <a:off x="9825198" y="3211753"/>
             <a:ext cx="1645920" cy="457200"/>
           </a:xfrm>
           <a:prstGeom prst="rect">
@@ -2403,7 +2191,7 @@
           <a:bodyPr wrap="square" rtlCol="0" anchor="t"/>
           <a:lstStyle/>
           <a:p>
-            <a:pPr indent="0" marL="0">
+            <a:pPr marL="0" indent="0">
               <a:buNone/>
             </a:pPr>
             <a:r>
@@ -2420,7 +2208,7 @@
             <a:endParaRPr lang="en-US" sz="1100" dirty="0"/>
           </a:p>
           <a:p>
-            <a:pPr indent="0" marL="0">
+            <a:pPr marL="0" indent="0">
               <a:buNone/>
             </a:pPr>
             <a:r>
@@ -2446,7 +2234,7 @@
         </p:nvSpPr>
         <p:spPr>
           <a:xfrm>
-            <a:off x="2468880" y="2926080"/>
+            <a:off x="2418558" y="3257473"/>
             <a:ext cx="182880" cy="914"/>
           </a:xfrm>
           <a:prstGeom prst="line">
@@ -2462,6 +2250,13 @@
             <a:tailEnd type="triangle"/>
           </a:ln>
         </p:spPr>
+        <p:txBody>
+          <a:bodyPr/>
+          <a:lstStyle/>
+          <a:p>
+            <a:endParaRPr lang="en-ES"/>
+          </a:p>
+        </p:txBody>
       </p:sp>
       <p:sp>
         <p:nvSpPr>
@@ -2471,7 +2266,7 @@
         </p:nvSpPr>
         <p:spPr>
           <a:xfrm>
-            <a:off x="5486400" y="2926080"/>
+            <a:off x="5436078" y="3257473"/>
             <a:ext cx="274320" cy="914"/>
           </a:xfrm>
           <a:prstGeom prst="line">
@@ -2487,6 +2282,13 @@
             <a:tailEnd type="triangle"/>
           </a:ln>
         </p:spPr>
+        <p:txBody>
+          <a:bodyPr/>
+          <a:lstStyle/>
+          <a:p>
+            <a:endParaRPr lang="en-ES"/>
+          </a:p>
+        </p:txBody>
       </p:sp>
       <p:sp>
         <p:nvSpPr>
@@ -2496,7 +2298,7 @@
         </p:nvSpPr>
         <p:spPr>
           <a:xfrm>
-            <a:off x="9326880" y="2926080"/>
+            <a:off x="9276558" y="3257473"/>
             <a:ext cx="365760" cy="914"/>
           </a:xfrm>
           <a:prstGeom prst="line">
@@ -2512,121 +2314,11 @@
             <a:tailEnd type="triangle"/>
           </a:ln>
         </p:spPr>
-      </p:sp>
-      <p:sp>
-        <p:nvSpPr>
-          <p:cNvPr id="19" name="Text 17"/>
-          <p:cNvSpPr/>
-          <p:nvPr/>
-        </p:nvSpPr>
-        <p:spPr>
-          <a:xfrm>
-            <a:off x="1874520" y="2697480"/>
-            <a:ext cx="731520" cy="274320"/>
-          </a:xfrm>
-          <a:prstGeom prst="rect">
-            <a:avLst/>
-          </a:prstGeom>
-          <a:noFill/>
-          <a:ln/>
-        </p:spPr>
-        <p:txBody>
-          <a:bodyPr wrap="square" rtlCol="0" anchor="ctr"/>
-          <a:lstStyle/>
-          <a:p>
-            <a:pPr indent="0" marL="0">
-              <a:buNone/>
-            </a:pPr>
-            <a:r>
-              <a:rPr lang="en-US" sz="900" dirty="0">
-                <a:solidFill>
-                  <a:srgbClr val="475569"/>
-                </a:solidFill>
-                <a:latin typeface="Arial" pitchFamily="34" charset="0"/>
-                <a:ea typeface="Arial" pitchFamily="34" charset="-122"/>
-                <a:cs typeface="Arial" pitchFamily="34" charset="-120"/>
-              </a:rPr>
-              <a:t>chat</a:t>
-            </a:r>
-            <a:endParaRPr lang="en-US" sz="900" dirty="0"/>
-          </a:p>
-        </p:txBody>
-      </p:sp>
-      <p:sp>
-        <p:nvSpPr>
-          <p:cNvPr id="20" name="Text 18"/>
-          <p:cNvSpPr/>
-          <p:nvPr/>
-        </p:nvSpPr>
-        <p:spPr>
-          <a:xfrm>
-            <a:off x="4800600" y="2697480"/>
-            <a:ext cx="914400" cy="274320"/>
-          </a:xfrm>
-          <a:prstGeom prst="rect">
-            <a:avLst/>
-          </a:prstGeom>
-          <a:noFill/>
-          <a:ln/>
-        </p:spPr>
-        <p:txBody>
-          <a:bodyPr wrap="square" rtlCol="0" anchor="ctr"/>
-          <a:lstStyle/>
-          <a:p>
-            <a:pPr indent="0" marL="0">
-              <a:buNone/>
-            </a:pPr>
-            <a:r>
-              <a:rPr lang="en-US" sz="900" dirty="0">
-                <a:solidFill>
-                  <a:srgbClr val="475569"/>
-                </a:solidFill>
-                <a:latin typeface="Arial" pitchFamily="34" charset="0"/>
-                <a:ea typeface="Arial" pitchFamily="34" charset="-122"/>
-                <a:cs typeface="Arial" pitchFamily="34" charset="-120"/>
-              </a:rPr>
-              <a:t>SDK calls</a:t>
-            </a:r>
-            <a:endParaRPr lang="en-US" sz="900" dirty="0"/>
-          </a:p>
-        </p:txBody>
-      </p:sp>
-      <p:sp>
-        <p:nvSpPr>
-          <p:cNvPr id="21" name="Text 19"/>
-          <p:cNvSpPr/>
-          <p:nvPr/>
-        </p:nvSpPr>
-        <p:spPr>
-          <a:xfrm>
-            <a:off x="8869680" y="2697480"/>
-            <a:ext cx="914400" cy="274320"/>
-          </a:xfrm>
-          <a:prstGeom prst="rect">
-            <a:avLst/>
-          </a:prstGeom>
-          <a:noFill/>
-          <a:ln/>
-        </p:spPr>
-        <p:txBody>
-          <a:bodyPr wrap="square" rtlCol="0" anchor="ctr"/>
-          <a:lstStyle/>
-          <a:p>
-            <a:pPr indent="0" marL="0">
-              <a:buNone/>
-            </a:pPr>
-            <a:r>
-              <a:rPr lang="en-US" sz="900" dirty="0">
-                <a:solidFill>
-                  <a:srgbClr val="475569"/>
-                </a:solidFill>
-                <a:latin typeface="Arial" pitchFamily="34" charset="0"/>
-                <a:ea typeface="Arial" pitchFamily="34" charset="-122"/>
-                <a:cs typeface="Arial" pitchFamily="34" charset="-120"/>
-              </a:rPr>
-              <a:t>messages</a:t>
-            </a:r>
-            <a:endParaRPr lang="en-US" sz="900" dirty="0"/>
+        <p:txBody>
+          <a:bodyPr/>
+          <a:lstStyle/>
+          <a:p>
+            <a:endParaRPr lang="en-ES"/>
           </a:p>
         </p:txBody>
       </p:sp>
@@ -2638,8 +2330,8 @@
         </p:nvSpPr>
         <p:spPr>
           <a:xfrm>
-            <a:off x="731520" y="5852160"/>
-            <a:ext cx="11155680" cy="685800"/>
+            <a:off x="731520" y="6126480"/>
+            <a:ext cx="11155680" cy="480060"/>
           </a:xfrm>
           <a:prstGeom prst="roundRect">
             <a:avLst/>
@@ -2654,6 +2346,13 @@
             <a:prstDash val="solid"/>
           </a:ln>
         </p:spPr>
+        <p:txBody>
+          <a:bodyPr/>
+          <a:lstStyle/>
+          <a:p>
+            <a:endParaRPr lang="en-ES"/>
+          </a:p>
+        </p:txBody>
       </p:sp>
       <p:sp>
         <p:nvSpPr>
@@ -2663,8 +2362,8 @@
         </p:nvSpPr>
         <p:spPr>
           <a:xfrm>
-            <a:off x="960120" y="5961888"/>
-            <a:ext cx="10698480" cy="411480"/>
+            <a:off x="935572" y="6217920"/>
+            <a:ext cx="10698480" cy="288036"/>
           </a:xfrm>
           <a:prstGeom prst="rect">
             <a:avLst/>
@@ -2676,9 +2375,6 @@
           <a:bodyPr wrap="square" rtlCol="0" anchor="ctr"/>
           <a:lstStyle/>
           <a:p>
-            <a:pPr indent="0" marL="0">
-              <a:buNone/>
-            </a:pPr>
             <a:r>
               <a:rPr lang="en-US" sz="1100" dirty="0">
                 <a:solidFill>
@@ -2688,9 +2384,12 @@
                 <a:ea typeface="Arial" pitchFamily="34" charset="-122"/>
                 <a:cs typeface="Arial" pitchFamily="34" charset="-120"/>
               </a:rPr>
-              <a:t>Auth note: Backstage GitHub OAuth login is reused to authenticate Copilot SDK sessions, enabling a seamless sign-in experience.</a:t>
-            </a:r>
-            <a:endParaRPr lang="en-US" sz="1100" dirty="0"/>
+              <a:t>Auth note: </a:t>
+            </a:r>
+            <a:r>
+              <a:rPr lang="en-GB" sz="1100" dirty="0"/>
+              <a:t>Backstage GitHub OAuth login is reused for Copilot SDK sessions.</a:t>
+            </a:r>
           </a:p>
         </p:txBody>
       </p:sp>
@@ -2995,4 +2694,319 @@
     </a:ext>
   </a:extLst>
 </a:theme>
+</file>
+
+<file path=ppt/theme/theme2.xml><?xml version="1.0" encoding="utf-8"?>
+<a:theme xmlns:a="http://schemas.openxmlformats.org/drawingml/2006/main" name="Office Theme">
+  <a:themeElements>
+    <a:clrScheme name="Office">
+      <a:dk1>
+        <a:sysClr val="windowText" lastClr="000000"/>
+      </a:dk1>
+      <a:lt1>
+        <a:sysClr val="window" lastClr="FFFFFF"/>
+      </a:lt1>
+      <a:dk2>
+        <a:srgbClr val="0E2841"/>
+      </a:dk2>
+      <a:lt2>
+        <a:srgbClr val="E8E8E8"/>
+      </a:lt2>
+      <a:accent1>
+        <a:srgbClr val="156082"/>
+      </a:accent1>
+      <a:accent2>
+        <a:srgbClr val="E97132"/>
+      </a:accent2>
+      <a:accent3>
+        <a:srgbClr val="196B24"/>
+      </a:accent3>
+      <a:accent4>
+        <a:srgbClr val="0F9ED5"/>
+      </a:accent4>
+      <a:accent5>
+        <a:srgbClr val="A02B93"/>
+      </a:accent5>
+      <a:accent6>
+        <a:srgbClr val="4EA72E"/>
+      </a:accent6>
+      <a:hlink>
+        <a:srgbClr val="467886"/>
+      </a:hlink>
+      <a:folHlink>
+        <a:srgbClr val="96607D"/>
+      </a:folHlink>
+    </a:clrScheme>
+    <a:fontScheme name="Office">
+      <a:majorFont>
+        <a:latin typeface="Aptos Display" panose="02110004020202020204"/>
+        <a:ea typeface=""/>
+        <a:cs typeface=""/>
+        <a:font script="Jpan" typeface="游ゴシック Light"/>
+        <a:font script="Hang" typeface="맑은 고딕"/>
+        <a:font script="Hans" typeface="等线 Light"/>
+        <a:font script="Hant" typeface="新細明體"/>
+        <a:font script="Arab" typeface="Times New Roman"/>
+        <a:font script="Hebr" typeface="Times New Roman"/>
+        <a:font script="Thai" typeface="Angsana New"/>
+        <a:font script="Ethi" typeface="Nyala"/>
+        <a:font script="Beng" typeface="Vrinda"/>
+        <a:font script="Gujr" typeface="Shruti"/>
+        <a:font script="Khmr" typeface="MoolBoran"/>
+        <a:font script="Knda" typeface="Tunga"/>
+        <a:font script="Guru" typeface="Raavi"/>
+        <a:font script="Cans" typeface="Euphemia"/>
+        <a:font script="Cher" typeface="Plantagenet Cherokee"/>
+        <a:font script="Yiii" typeface="Microsoft Yi Baiti"/>
+        <a:font script="Tibt" typeface="Microsoft Himalaya"/>
+        <a:font script="Thaa" typeface="MV Boli"/>
+        <a:font script="Deva" typeface="Mangal"/>
+        <a:font script="Telu" typeface="Gautami"/>
+        <a:font script="Taml" typeface="Latha"/>
+        <a:font script="Syrc" typeface="Estrangelo Edessa"/>
+        <a:font script="Orya" typeface="Kalinga"/>
+        <a:font script="Mlym" typeface="Kartika"/>
+        <a:font script="Laoo" typeface="DokChampa"/>
+        <a:font script="Sinh" typeface="Iskoola Pota"/>
+        <a:font script="Mong" typeface="Mongolian Baiti"/>
+        <a:font script="Viet" typeface="Times New Roman"/>
+        <a:font script="Uigh" typeface="Microsoft Uighur"/>
+        <a:font script="Geor" typeface="Sylfaen"/>
+        <a:font script="Armn" typeface="Arial"/>
+        <a:font script="Bugi" typeface="Leelawadee UI"/>
+        <a:font script="Bopo" typeface="Microsoft JhengHei"/>
+        <a:font script="Java" typeface="Javanese Text"/>
+        <a:font script="Lisu" typeface="Segoe UI"/>
+        <a:font script="Mymr" typeface="Myanmar Text"/>
+        <a:font script="Nkoo" typeface="Ebrima"/>
+        <a:font script="Olck" typeface="Nirmala UI"/>
+        <a:font script="Osma" typeface="Ebrima"/>
+        <a:font script="Phag" typeface="Phagspa"/>
+        <a:font script="Syrn" typeface="Estrangelo Edessa"/>
+        <a:font script="Syrj" typeface="Estrangelo Edessa"/>
+        <a:font script="Syre" typeface="Estrangelo Edessa"/>
+        <a:font script="Sora" typeface="Nirmala UI"/>
+        <a:font script="Tale" typeface="Microsoft Tai Le"/>
+        <a:font script="Talu" typeface="Microsoft New Tai Lue"/>
+        <a:font script="Tfng" typeface="Ebrima"/>
+      </a:majorFont>
+      <a:minorFont>
+        <a:latin typeface="Aptos" panose="02110004020202020204"/>
+        <a:ea typeface=""/>
+        <a:cs typeface=""/>
+        <a:font script="Jpan" typeface="游ゴシック"/>
+        <a:font script="Hang" typeface="맑은 고딕"/>
+        <a:font script="Hans" typeface="等线"/>
+        <a:font script="Hant" typeface="新細明體"/>
+        <a:font script="Arab" typeface="Arial"/>
+        <a:font script="Hebr" typeface="Arial"/>
+        <a:font script="Thai" typeface="Cordia New"/>
+        <a:font script="Ethi" typeface="Nyala"/>
+        <a:font script="Beng" typeface="Vrinda"/>
+        <a:font script="Gujr" typeface="Shruti"/>
+        <a:font script="Khmr" typeface="DaunPenh"/>
+        <a:font script="Knda" typeface="Tunga"/>
+        <a:font script="Guru" typeface="Raavi"/>
+        <a:font script="Cans" typeface="Euphemia"/>
+        <a:font script="Cher" typeface="Plantagenet Cherokee"/>
+        <a:font script="Yiii" typeface="Microsoft Yi Baiti"/>
+        <a:font script="Tibt" typeface="Microsoft Himalaya"/>
+        <a:font script="Thaa" typeface="MV Boli"/>
+        <a:font script="Deva" typeface="Mangal"/>
+        <a:font script="Telu" typeface="Gautami"/>
+        <a:font script="Taml" typeface="Latha"/>
+        <a:font script="Syrc" typeface="Estrangelo Edessa"/>
+        <a:font script="Orya" typeface="Kalinga"/>
+        <a:font script="Mlym" typeface="Kartika"/>
+        <a:font script="Laoo" typeface="DokChampa"/>
+        <a:font script="Sinh" typeface="Iskoola Pota"/>
+        <a:font script="Mong" typeface="Mongolian Baiti"/>
+        <a:font script="Viet" typeface="Arial"/>
+        <a:font script="Uigh" typeface="Microsoft Uighur"/>
+        <a:font script="Geor" typeface="Sylfaen"/>
+        <a:font script="Armn" typeface="Arial"/>
+        <a:font script="Bugi" typeface="Leelawadee UI"/>
+        <a:font script="Bopo" typeface="Microsoft JhengHei"/>
+        <a:font script="Java" typeface="Javanese Text"/>
+        <a:font script="Lisu" typeface="Segoe UI"/>
+        <a:font script="Mymr" typeface="Myanmar Text"/>
+        <a:font script="Nkoo" typeface="Ebrima"/>
+        <a:font script="Olck" typeface="Nirmala UI"/>
+        <a:font script="Osma" typeface="Ebrima"/>
+        <a:font script="Phag" typeface="Phagspa"/>
+        <a:font script="Syrn" typeface="Estrangelo Edessa"/>
+        <a:font script="Syrj" typeface="Estrangelo Edessa"/>
+        <a:font script="Syre" typeface="Estrangelo Edessa"/>
+        <a:font script="Sora" typeface="Nirmala UI"/>
+        <a:font script="Tale" typeface="Microsoft Tai Le"/>
+        <a:font script="Talu" typeface="Microsoft New Tai Lue"/>
+        <a:font script="Tfng" typeface="Ebrima"/>
+      </a:minorFont>
+    </a:fontScheme>
+    <a:fmtScheme name="Office">
+      <a:fillStyleLst>
+        <a:solidFill>
+          <a:schemeClr val="phClr"/>
+        </a:solidFill>
+        <a:gradFill rotWithShape="1">
+          <a:gsLst>
+            <a:gs pos="0">
+              <a:schemeClr val="phClr">
+                <a:lumMod val="110000"/>
+                <a:satMod val="105000"/>
+                <a:tint val="67000"/>
+              </a:schemeClr>
+            </a:gs>
+            <a:gs pos="50000">
+              <a:schemeClr val="phClr">
+                <a:lumMod val="105000"/>
+                <a:satMod val="103000"/>
+                <a:tint val="73000"/>
+              </a:schemeClr>
+            </a:gs>
+            <a:gs pos="100000">
+              <a:schemeClr val="phClr">
+                <a:lumMod val="105000"/>
+                <a:satMod val="109000"/>
+                <a:tint val="81000"/>
+              </a:schemeClr>
+            </a:gs>
+          </a:gsLst>
+          <a:lin ang="5400000" scaled="0"/>
+        </a:gradFill>
+        <a:gradFill rotWithShape="1">
+          <a:gsLst>
+            <a:gs pos="0">
+              <a:schemeClr val="phClr">
+                <a:satMod val="103000"/>
+                <a:lumMod val="102000"/>
+                <a:tint val="94000"/>
+              </a:schemeClr>
+            </a:gs>
+            <a:gs pos="50000">
+              <a:schemeClr val="phClr">
+                <a:satMod val="110000"/>
+                <a:lumMod val="100000"/>
+                <a:shade val="100000"/>
+              </a:schemeClr>
+            </a:gs>
+            <a:gs pos="100000">
+              <a:schemeClr val="phClr">
+                <a:lumMod val="99000"/>
+                <a:satMod val="120000"/>
+                <a:shade val="78000"/>
+              </a:schemeClr>
+            </a:gs>
+          </a:gsLst>
+          <a:lin ang="5400000" scaled="0"/>
+        </a:gradFill>
+      </a:fillStyleLst>
+      <a:lnStyleLst>
+        <a:ln w="12700" cap="flat" cmpd="sng" algn="ctr">
+          <a:solidFill>
+            <a:schemeClr val="phClr"/>
+          </a:solidFill>
+          <a:prstDash val="solid"/>
+          <a:miter lim="800000"/>
+        </a:ln>
+        <a:ln w="19050" cap="flat" cmpd="sng" algn="ctr">
+          <a:solidFill>
+            <a:schemeClr val="phClr"/>
+          </a:solidFill>
+          <a:prstDash val="solid"/>
+          <a:miter lim="800000"/>
+        </a:ln>
+        <a:ln w="25400" cap="flat" cmpd="sng" algn="ctr">
+          <a:solidFill>
+            <a:schemeClr val="phClr"/>
+          </a:solidFill>
+          <a:prstDash val="solid"/>
+          <a:miter lim="800000"/>
+        </a:ln>
+      </a:lnStyleLst>
+      <a:effectStyleLst>
+        <a:effectStyle>
+          <a:effectLst/>
+        </a:effectStyle>
+        <a:effectStyle>
+          <a:effectLst/>
+        </a:effectStyle>
+        <a:effectStyle>
+          <a:effectLst>
+            <a:outerShdw blurRad="57150" dist="19050" dir="5400000" algn="ctr" rotWithShape="0">
+              <a:srgbClr val="000000">
+                <a:alpha val="63000"/>
+              </a:srgbClr>
+            </a:outerShdw>
+          </a:effectLst>
+        </a:effectStyle>
+      </a:effectStyleLst>
+      <a:bgFillStyleLst>
+        <a:solidFill>
+          <a:schemeClr val="phClr"/>
+        </a:solidFill>
+        <a:solidFill>
+          <a:schemeClr val="phClr">
+            <a:tint val="95000"/>
+            <a:satMod val="170000"/>
+          </a:schemeClr>
+        </a:solidFill>
+        <a:gradFill rotWithShape="1">
+          <a:gsLst>
+            <a:gs pos="0">
+              <a:schemeClr val="phClr">
+                <a:tint val="93000"/>
+                <a:satMod val="150000"/>
+                <a:shade val="98000"/>
+                <a:lumMod val="102000"/>
+              </a:schemeClr>
+            </a:gs>
+            <a:gs pos="50000">
+              <a:schemeClr val="phClr">
+                <a:tint val="98000"/>
+                <a:satMod val="130000"/>
+                <a:shade val="90000"/>
+                <a:lumMod val="103000"/>
+              </a:schemeClr>
+            </a:gs>
+            <a:gs pos="100000">
+              <a:schemeClr val="phClr">
+                <a:shade val="63000"/>
+                <a:satMod val="120000"/>
+              </a:schemeClr>
+            </a:gs>
+          </a:gsLst>
+          <a:lin ang="5400000" scaled="0"/>
+        </a:gradFill>
+      </a:bgFillStyleLst>
+    </a:fmtScheme>
+  </a:themeElements>
+  <a:objectDefaults>
+    <a:lnDef>
+      <a:spPr/>
+      <a:bodyPr/>
+      <a:lstStyle/>
+      <a:style>
+        <a:lnRef idx="2">
+          <a:schemeClr val="accent1"/>
+        </a:lnRef>
+        <a:fillRef idx="0">
+          <a:schemeClr val="accent1"/>
+        </a:fillRef>
+        <a:effectRef idx="1">
+          <a:schemeClr val="accent1"/>
+        </a:effectRef>
+        <a:fontRef idx="minor">
+          <a:schemeClr val="tx1"/>
+        </a:fontRef>
+      </a:style>
+    </a:lnDef>
+  </a:objectDefaults>
+  <a:extraClrSchemeLst/>
+  <a:extLst>
+    <a:ext uri="{05A4C25C-085E-4340-85A3-A5531E510DB2}">
+      <thm15:themeFamily xmlns:thm15="http://schemas.microsoft.com/office/thememl/2012/main" name="Office Theme" id="{2E142A2C-CD16-42D6-873A-C26D2A0506FA}" vid="{1BDDFF52-6CD6-40A5-AB3C-68EB2F1E4D0A}"/>
+    </a:ext>
+  </a:extLst>
+</a:theme>
 </file>
</xml_diff>